<commit_message>
Add presenter preparation guide
</commit_message>
<xml_diff>
--- a/NewsLens_AAT_Presentation.pptx
+++ b/NewsLens_AAT_Presentation.pptx
@@ -3108,119 +3108,50 @@
         </p:nvSpPr>
         <p:spPr>
           <a:xfrm>
-            <a:off x="658368" y="502920"/>
-            <a:ext cx="4114800" cy="274320"/>
-          </a:xfrm>
-          <a:prstGeom prst="rect">
-            <a:avLst/>
-          </a:prstGeom>
-          <a:noFill/>
-        </p:spPr>
-        <p:txBody>
-          <a:bodyPr wrap="square" lIns="36576" rIns="36576" tIns="36576" bIns="36576" anchor="t">
-            <a:spAutoFit/>
-          </a:bodyPr>
-          <a:lstStyle/>
-          <a:p>
-            <a:pPr algn="l"/>
-            <a:r>
-              <a:rPr sz="1000" b="1">
-                <a:solidFill>
-                  <a:srgbClr val="C6F432"/>
-                </a:solidFill>
-                <a:latin typeface="Courier New"/>
-              </a:rPr>
-              <a:t>NLP APPLICATION / AAT</a:t>
-            </a:r>
-          </a:p>
-        </p:txBody>
-      </p:sp>
-      <p:sp>
-        <p:nvSpPr>
-          <p:cNvPr id="3" name="TextBox 2"/>
-          <p:cNvSpPr txBox="1"/>
-          <p:nvPr/>
-        </p:nvSpPr>
-        <p:spPr>
-          <a:xfrm>
-            <a:off x="658368" y="1463040"/>
-            <a:ext cx="6583680" cy="777240"/>
-          </a:xfrm>
-          <a:prstGeom prst="rect">
-            <a:avLst/>
-          </a:prstGeom>
-          <a:noFill/>
-        </p:spPr>
-        <p:txBody>
-          <a:bodyPr wrap="square" lIns="36576" rIns="36576" tIns="36576" bIns="36576" anchor="t">
-            <a:spAutoFit/>
-          </a:bodyPr>
-          <a:lstStyle/>
-          <a:p>
-            <a:pPr algn="l"/>
-            <a:r>
-              <a:rPr sz="5200" b="1">
+            <a:off x="914400" y="658368"/>
+            <a:ext cx="10378440" cy="1600200"/>
+          </a:xfrm>
+          <a:prstGeom prst="rect">
+            <a:avLst/>
+          </a:prstGeom>
+          <a:noFill/>
+        </p:spPr>
+        <p:txBody>
+          <a:bodyPr wrap="square" lIns="9144" rIns="9144" tIns="9144" bIns="9144" anchor="ctr">
+            <a:spAutoFit/>
+          </a:bodyPr>
+          <a:lstStyle/>
+          <a:p>
+            <a:pPr algn="ctr"/>
+            <a:r>
+              <a:rPr sz="2700" b="1">
                 <a:solidFill>
                   <a:srgbClr val="EEF0F3"/>
                 </a:solidFill>
                 <a:latin typeface="Cambria"/>
               </a:rPr>
-              <a:t>NewsLens</a:t>
-            </a:r>
-          </a:p>
-        </p:txBody>
-      </p:sp>
-      <p:sp>
-        <p:nvSpPr>
-          <p:cNvPr id="4" name="TextBox 3"/>
-          <p:cNvSpPr txBox="1"/>
-          <p:nvPr/>
-        </p:nvSpPr>
-        <p:spPr>
-          <a:xfrm>
-            <a:off x="694944" y="2267712"/>
-            <a:ext cx="5943600" cy="731520"/>
-          </a:xfrm>
-          <a:prstGeom prst="rect">
-            <a:avLst/>
-          </a:prstGeom>
-          <a:noFill/>
-        </p:spPr>
-        <p:txBody>
-          <a:bodyPr wrap="square" lIns="36576" rIns="36576" tIns="36576" bIns="36576" anchor="t">
-            <a:spAutoFit/>
-          </a:bodyPr>
-          <a:lstStyle/>
-          <a:p>
-            <a:pPr algn="l"/>
-            <a:r>
-              <a:rPr sz="2200" b="0">
-                <a:solidFill>
-                  <a:srgbClr val="AEB8C4"/>
-                </a:solidFill>
-                <a:latin typeface="Aptos"/>
-              </a:rPr>
-              <a:t>Explainable fake news detection
-using natural language processing</a:t>
+              <a:t>NewsLens: Explainable Fake News
+Detection Using Natural Language
+Processing</a:t>
             </a:r>
           </a:p>
         </p:txBody>
       </p:sp>
       <p:cxnSp>
         <p:nvCxnSpPr>
-          <p:cNvPr id="5" name="Connector 4"/>
+          <p:cNvPr id="3" name="Connector 2"/>
           <p:cNvCxnSpPr/>
           <p:nvPr/>
         </p:nvCxnSpPr>
         <p:spPr>
           <a:xfrm>
-            <a:off x="694944" y="3337560"/>
-            <a:ext cx="4334256" cy="0"/>
+            <a:off x="3566160" y="2542032"/>
+            <a:ext cx="2011680" cy="0"/>
           </a:xfrm>
           <a:prstGeom prst="line">
             <a:avLst/>
           </a:prstGeom>
-          <a:ln w="25400">
+          <a:ln w="17780">
             <a:solidFill>
               <a:srgbClr val="C6F432"/>
             </a:solidFill>
@@ -3243,409 +3174,24 @@
       </p:cxnSp>
       <p:sp>
         <p:nvSpPr>
-          <p:cNvPr id="6" name="TextBox 5"/>
-          <p:cNvSpPr txBox="1"/>
-          <p:nvPr/>
-        </p:nvSpPr>
-        <p:spPr>
-          <a:xfrm>
-            <a:off x="694944" y="3703320"/>
-            <a:ext cx="2011680" cy="219456"/>
-          </a:xfrm>
-          <a:prstGeom prst="rect">
-            <a:avLst/>
-          </a:prstGeom>
-          <a:noFill/>
-        </p:spPr>
-        <p:txBody>
-          <a:bodyPr wrap="square" lIns="36576" rIns="36576" tIns="36576" bIns="36576" anchor="t">
-            <a:spAutoFit/>
-          </a:bodyPr>
-          <a:lstStyle/>
-          <a:p>
-            <a:pPr algn="l"/>
-            <a:r>
-              <a:rPr sz="900" b="1">
-                <a:solidFill>
-                  <a:srgbClr val="C6F432"/>
-                </a:solidFill>
-                <a:latin typeface="Courier New"/>
-              </a:rPr>
-              <a:t>PRESENTED BY</a:t>
-            </a:r>
-          </a:p>
-        </p:txBody>
-      </p:sp>
-      <p:sp>
-        <p:nvSpPr>
-          <p:cNvPr id="7" name="TextBox 6"/>
-          <p:cNvSpPr txBox="1"/>
-          <p:nvPr/>
-        </p:nvSpPr>
-        <p:spPr>
-          <a:xfrm>
-            <a:off x="694944" y="4005072"/>
-            <a:ext cx="1325880" cy="384048"/>
-          </a:xfrm>
-          <a:prstGeom prst="rect">
-            <a:avLst/>
-          </a:prstGeom>
-          <a:noFill/>
-        </p:spPr>
-        <p:txBody>
-          <a:bodyPr wrap="square" lIns="36576" rIns="36576" tIns="36576" bIns="36576" anchor="t">
-            <a:spAutoFit/>
-          </a:bodyPr>
-          <a:lstStyle/>
-          <a:p>
-            <a:pPr algn="l"/>
-            <a:r>
-              <a:rPr sz="1050" b="1">
-                <a:solidFill>
-                  <a:srgbClr val="EEF0F3"/>
-                </a:solidFill>
-                <a:latin typeface="Aptos"/>
-              </a:rPr>
-              <a:t>Hitesh Sharma</a:t>
-            </a:r>
-          </a:p>
-        </p:txBody>
-      </p:sp>
-      <p:sp>
-        <p:nvSpPr>
-          <p:cNvPr id="8" name="TextBox 7"/>
-          <p:cNvSpPr txBox="1"/>
-          <p:nvPr/>
-        </p:nvSpPr>
-        <p:spPr>
-          <a:xfrm>
-            <a:off x="694944" y="4443984"/>
-            <a:ext cx="1325880" cy="228600"/>
-          </a:xfrm>
-          <a:prstGeom prst="rect">
-            <a:avLst/>
-          </a:prstGeom>
-          <a:noFill/>
-        </p:spPr>
-        <p:txBody>
-          <a:bodyPr wrap="square" lIns="36576" rIns="36576" tIns="36576" bIns="36576" anchor="t">
-            <a:spAutoFit/>
-          </a:bodyPr>
-          <a:lstStyle/>
-          <a:p>
-            <a:pPr algn="l"/>
-            <a:r>
-              <a:rPr sz="750" b="0">
-                <a:solidFill>
-                  <a:srgbClr val="AEB8C4"/>
-                </a:solidFill>
-                <a:latin typeface="Courier New"/>
-              </a:rPr>
-              <a:t>USN: __________</a:t>
-            </a:r>
-          </a:p>
-        </p:txBody>
-      </p:sp>
-      <p:sp>
-        <p:nvSpPr>
-          <p:cNvPr id="9" name="TextBox 8"/>
-          <p:cNvSpPr txBox="1"/>
-          <p:nvPr/>
-        </p:nvSpPr>
-        <p:spPr>
-          <a:xfrm>
-            <a:off x="1993392" y="4005072"/>
-            <a:ext cx="1325880" cy="384048"/>
-          </a:xfrm>
-          <a:prstGeom prst="rect">
-            <a:avLst/>
-          </a:prstGeom>
-          <a:noFill/>
-        </p:spPr>
-        <p:txBody>
-          <a:bodyPr wrap="square" lIns="36576" rIns="36576" tIns="36576" bIns="36576" anchor="t">
-            <a:spAutoFit/>
-          </a:bodyPr>
-          <a:lstStyle/>
-          <a:p>
-            <a:pPr algn="l"/>
-            <a:r>
-              <a:rPr sz="1050" b="1">
-                <a:solidFill>
-                  <a:srgbClr val="EEF0F3"/>
-                </a:solidFill>
-                <a:latin typeface="Aptos"/>
-              </a:rPr>
-              <a:t>Ghanshyam Sharma</a:t>
-            </a:r>
-          </a:p>
-        </p:txBody>
-      </p:sp>
-      <p:sp>
-        <p:nvSpPr>
-          <p:cNvPr id="10" name="TextBox 9"/>
-          <p:cNvSpPr txBox="1"/>
-          <p:nvPr/>
-        </p:nvSpPr>
-        <p:spPr>
-          <a:xfrm>
-            <a:off x="1993392" y="4443984"/>
-            <a:ext cx="1325880" cy="228600"/>
-          </a:xfrm>
-          <a:prstGeom prst="rect">
-            <a:avLst/>
-          </a:prstGeom>
-          <a:noFill/>
-        </p:spPr>
-        <p:txBody>
-          <a:bodyPr wrap="square" lIns="36576" rIns="36576" tIns="36576" bIns="36576" anchor="t">
-            <a:spAutoFit/>
-          </a:bodyPr>
-          <a:lstStyle/>
-          <a:p>
-            <a:pPr algn="l"/>
-            <a:r>
-              <a:rPr sz="750" b="0">
-                <a:solidFill>
-                  <a:srgbClr val="AEB8C4"/>
-                </a:solidFill>
-                <a:latin typeface="Courier New"/>
-              </a:rPr>
-              <a:t>1BM23CS100</a:t>
-            </a:r>
-          </a:p>
-        </p:txBody>
-      </p:sp>
-      <p:sp>
-        <p:nvSpPr>
-          <p:cNvPr id="11" name="TextBox 10"/>
-          <p:cNvSpPr txBox="1"/>
-          <p:nvPr/>
-        </p:nvSpPr>
-        <p:spPr>
-          <a:xfrm>
-            <a:off x="3456432" y="4005072"/>
-            <a:ext cx="1325880" cy="384048"/>
-          </a:xfrm>
-          <a:prstGeom prst="rect">
-            <a:avLst/>
-          </a:prstGeom>
-          <a:noFill/>
-        </p:spPr>
-        <p:txBody>
-          <a:bodyPr wrap="square" lIns="36576" rIns="36576" tIns="36576" bIns="36576" anchor="t">
-            <a:spAutoFit/>
-          </a:bodyPr>
-          <a:lstStyle/>
-          <a:p>
-            <a:pPr algn="l"/>
-            <a:r>
-              <a:rPr sz="1050" b="1">
-                <a:solidFill>
-                  <a:srgbClr val="EEF0F3"/>
-                </a:solidFill>
-                <a:latin typeface="Aptos"/>
-              </a:rPr>
-              <a:t>Shreyash Shaurya</a:t>
-            </a:r>
-          </a:p>
-        </p:txBody>
-      </p:sp>
-      <p:sp>
-        <p:nvSpPr>
-          <p:cNvPr id="12" name="TextBox 11"/>
-          <p:cNvSpPr txBox="1"/>
-          <p:nvPr/>
-        </p:nvSpPr>
-        <p:spPr>
-          <a:xfrm>
-            <a:off x="3456432" y="4443984"/>
-            <a:ext cx="1325880" cy="228600"/>
-          </a:xfrm>
-          <a:prstGeom prst="rect">
-            <a:avLst/>
-          </a:prstGeom>
-          <a:noFill/>
-        </p:spPr>
-        <p:txBody>
-          <a:bodyPr wrap="square" lIns="36576" rIns="36576" tIns="36576" bIns="36576" anchor="t">
-            <a:spAutoFit/>
-          </a:bodyPr>
-          <a:lstStyle/>
-          <a:p>
-            <a:pPr algn="l"/>
-            <a:r>
-              <a:rPr sz="750" b="0">
-                <a:solidFill>
-                  <a:srgbClr val="AEB8C4"/>
-                </a:solidFill>
-                <a:latin typeface="Courier New"/>
-              </a:rPr>
-              <a:t>1BM23CS354</a:t>
-            </a:r>
-          </a:p>
-        </p:txBody>
-      </p:sp>
-      <p:sp>
-        <p:nvSpPr>
-          <p:cNvPr id="13" name="TextBox 12"/>
-          <p:cNvSpPr txBox="1"/>
-          <p:nvPr/>
-        </p:nvSpPr>
-        <p:spPr>
-          <a:xfrm>
-            <a:off x="4828032" y="4005072"/>
-            <a:ext cx="1325880" cy="384048"/>
-          </a:xfrm>
-          <a:prstGeom prst="rect">
-            <a:avLst/>
-          </a:prstGeom>
-          <a:noFill/>
-        </p:spPr>
-        <p:txBody>
-          <a:bodyPr wrap="square" lIns="36576" rIns="36576" tIns="36576" bIns="36576" anchor="t">
-            <a:spAutoFit/>
-          </a:bodyPr>
-          <a:lstStyle/>
-          <a:p>
-            <a:pPr algn="l"/>
-            <a:r>
-              <a:rPr sz="1050" b="1">
-                <a:solidFill>
-                  <a:srgbClr val="EEF0F3"/>
-                </a:solidFill>
-                <a:latin typeface="Aptos"/>
-              </a:rPr>
-              <a:t>Utkrisht Umang</a:t>
-            </a:r>
-          </a:p>
-        </p:txBody>
-      </p:sp>
-      <p:sp>
-        <p:nvSpPr>
-          <p:cNvPr id="14" name="TextBox 13"/>
-          <p:cNvSpPr txBox="1"/>
-          <p:nvPr/>
-        </p:nvSpPr>
-        <p:spPr>
-          <a:xfrm>
-            <a:off x="4828032" y="4443984"/>
-            <a:ext cx="1325880" cy="228600"/>
-          </a:xfrm>
-          <a:prstGeom prst="rect">
-            <a:avLst/>
-          </a:prstGeom>
-          <a:noFill/>
-        </p:spPr>
-        <p:txBody>
-          <a:bodyPr wrap="square" lIns="36576" rIns="36576" tIns="36576" bIns="36576" anchor="t">
-            <a:spAutoFit/>
-          </a:bodyPr>
-          <a:lstStyle/>
-          <a:p>
-            <a:pPr algn="l"/>
-            <a:r>
-              <a:rPr sz="750" b="0">
-                <a:solidFill>
-                  <a:srgbClr val="AEB8C4"/>
-                </a:solidFill>
-                <a:latin typeface="Courier New"/>
-              </a:rPr>
-              <a:t>1BM23CS355</a:t>
-            </a:r>
-          </a:p>
-        </p:txBody>
-      </p:sp>
-      <p:sp>
-        <p:nvSpPr>
-          <p:cNvPr id="15" name="TextBox 14"/>
-          <p:cNvSpPr txBox="1"/>
-          <p:nvPr/>
-        </p:nvSpPr>
-        <p:spPr>
-          <a:xfrm>
-            <a:off x="694944" y="5029200"/>
-            <a:ext cx="5029200" cy="274320"/>
-          </a:xfrm>
-          <a:prstGeom prst="rect">
-            <a:avLst/>
-          </a:prstGeom>
-          <a:noFill/>
-        </p:spPr>
-        <p:txBody>
-          <a:bodyPr wrap="square" lIns="36576" rIns="36576" tIns="36576" bIns="36576" anchor="t">
-            <a:spAutoFit/>
-          </a:bodyPr>
-          <a:lstStyle/>
-          <a:p>
-            <a:pPr algn="l"/>
-            <a:r>
-              <a:rPr sz="1100" b="0">
-                <a:solidFill>
-                  <a:srgbClr val="AEB8C4"/>
-                </a:solidFill>
-                <a:latin typeface="Aptos"/>
-              </a:rPr>
-              <a:t>Department of Computer Science and Engineering</a:t>
-            </a:r>
-          </a:p>
-        </p:txBody>
-      </p:sp>
-      <p:sp>
-        <p:nvSpPr>
-          <p:cNvPr id="16" name="TextBox 15"/>
-          <p:cNvSpPr txBox="1"/>
-          <p:nvPr/>
-        </p:nvSpPr>
-        <p:spPr>
-          <a:xfrm>
-            <a:off x="694944" y="5577840"/>
-            <a:ext cx="5029200" cy="256032"/>
-          </a:xfrm>
-          <a:prstGeom prst="rect">
-            <a:avLst/>
-          </a:prstGeom>
-          <a:noFill/>
-        </p:spPr>
-        <p:txBody>
-          <a:bodyPr wrap="square" lIns="36576" rIns="36576" tIns="36576" bIns="36576" anchor="t">
-            <a:spAutoFit/>
-          </a:bodyPr>
-          <a:lstStyle/>
-          <a:p>
-            <a:pPr algn="l"/>
-            <a:r>
-              <a:rPr sz="1000" b="0">
-                <a:solidFill>
-                  <a:srgbClr val="AEB8C4"/>
-                </a:solidFill>
-                <a:latin typeface="Courier New"/>
-              </a:rPr>
-              <a:t>BMS College of Engineering · 2026</a:t>
-            </a:r>
-          </a:p>
-        </p:txBody>
-      </p:sp>
-      <p:sp>
-        <p:nvSpPr>
-          <p:cNvPr id="17" name="Rounded Rectangle 16"/>
+          <p:cNvPr id="4" name="Hexagon 3"/>
           <p:cNvSpPr/>
           <p:nvPr/>
         </p:nvSpPr>
         <p:spPr>
           <a:xfrm>
-            <a:off x="7406640" y="1005840"/>
-            <a:ext cx="3977639" cy="4892040"/>
-          </a:xfrm>
-          <a:prstGeom prst="roundRect">
+            <a:off x="5715000" y="2340864"/>
+            <a:ext cx="502920" cy="411480"/>
+          </a:xfrm>
+          <a:prstGeom prst="hexagon">
             <a:avLst/>
           </a:prstGeom>
           <a:solidFill>
-            <a:srgbClr val="1C232C"/>
+            <a:srgbClr val="10141A"/>
           </a:solidFill>
-          <a:ln w="8890">
+          <a:ln w="15240">
             <a:solidFill>
-              <a:srgbClr val="1C232C"/>
+              <a:srgbClr val="C6F432"/>
             </a:solidFill>
           </a:ln>
         </p:spPr>
@@ -3673,93 +3219,56 @@
       </p:sp>
       <p:sp>
         <p:nvSpPr>
-          <p:cNvPr id="18" name="TextBox 17"/>
-          <p:cNvSpPr txBox="1"/>
-          <p:nvPr/>
-        </p:nvSpPr>
-        <p:spPr>
-          <a:xfrm>
-            <a:off x="7818120" y="1417320"/>
-            <a:ext cx="3017520" cy="228600"/>
-          </a:xfrm>
-          <a:prstGeom prst="rect">
-            <a:avLst/>
-          </a:prstGeom>
-          <a:noFill/>
-        </p:spPr>
-        <p:txBody>
-          <a:bodyPr wrap="square" lIns="36576" rIns="36576" tIns="36576" bIns="36576" anchor="t">
-            <a:spAutoFit/>
-          </a:bodyPr>
-          <a:lstStyle/>
-          <a:p>
-            <a:pPr algn="l"/>
-            <a:r>
-              <a:rPr sz="1000" b="1">
+          <p:cNvPr id="5" name="TextBox 4"/>
+          <p:cNvSpPr txBox="1"/>
+          <p:nvPr/>
+        </p:nvSpPr>
+        <p:spPr>
+          <a:xfrm>
+            <a:off x="5715000" y="2368296"/>
+            <a:ext cx="502920" cy="301752"/>
+          </a:xfrm>
+          <a:prstGeom prst="rect">
+            <a:avLst/>
+          </a:prstGeom>
+          <a:noFill/>
+        </p:spPr>
+        <p:txBody>
+          <a:bodyPr wrap="square" lIns="9144" rIns="9144" tIns="9144" bIns="9144" anchor="ctr">
+            <a:spAutoFit/>
+          </a:bodyPr>
+          <a:lstStyle/>
+          <a:p>
+            <a:pPr algn="ctr"/>
+            <a:r>
+              <a:rPr sz="1200" b="1">
                 <a:solidFill>
                   <a:srgbClr val="C6F432"/>
                 </a:solidFill>
                 <a:latin typeface="Courier New"/>
               </a:rPr>
-              <a:t>THE QUESTION</a:t>
-            </a:r>
-          </a:p>
-        </p:txBody>
-      </p:sp>
-      <p:sp>
-        <p:nvSpPr>
-          <p:cNvPr id="19" name="TextBox 18"/>
-          <p:cNvSpPr txBox="1"/>
-          <p:nvPr/>
-        </p:nvSpPr>
-        <p:spPr>
-          <a:xfrm>
-            <a:off x="7818120" y="1810512"/>
-            <a:ext cx="2971800" cy="822960"/>
-          </a:xfrm>
-          <a:prstGeom prst="rect">
-            <a:avLst/>
-          </a:prstGeom>
-          <a:noFill/>
-        </p:spPr>
-        <p:txBody>
-          <a:bodyPr wrap="square" lIns="36576" rIns="36576" tIns="36576" bIns="36576" anchor="t">
-            <a:spAutoFit/>
-          </a:bodyPr>
-          <a:lstStyle/>
-          <a:p>
-            <a:pPr algn="l"/>
-            <a:r>
-              <a:rPr sz="2500" b="1">
-                <a:solidFill>
-                  <a:srgbClr val="EEF0F3"/>
-                </a:solidFill>
-                <a:latin typeface="Cambria"/>
-              </a:rPr>
-              <a:t>Can language
-help us pause
-before sharing?</a:t>
+              <a:t>N</a:t>
             </a:r>
           </a:p>
         </p:txBody>
       </p:sp>
       <p:cxnSp>
         <p:nvCxnSpPr>
-          <p:cNvPr id="20" name="Connector 19"/>
+          <p:cNvPr id="6" name="Connector 5"/>
           <p:cNvCxnSpPr/>
           <p:nvPr/>
         </p:nvCxnSpPr>
         <p:spPr>
           <a:xfrm>
-            <a:off x="7818120" y="3136391"/>
-            <a:ext cx="3108960" cy="0"/>
+            <a:off x="6446520" y="2542032"/>
+            <a:ext cx="2176272" cy="0"/>
           </a:xfrm>
           <a:prstGeom prst="line">
             <a:avLst/>
           </a:prstGeom>
-          <a:ln w="7620">
+          <a:ln w="17780">
             <a:solidFill>
-              <a:srgbClr val="AEB8C4"/>
+              <a:srgbClr val="C6F432"/>
             </a:solidFill>
           </a:ln>
         </p:spPr>
@@ -3780,350 +3289,490 @@
       </p:cxnSp>
       <p:sp>
         <p:nvSpPr>
-          <p:cNvPr id="21" name="TextBox 20"/>
-          <p:cNvSpPr txBox="1"/>
-          <p:nvPr/>
-        </p:nvSpPr>
-        <p:spPr>
-          <a:xfrm>
-            <a:off x="7818120" y="3246120"/>
-            <a:ext cx="822960" cy="182880"/>
-          </a:xfrm>
-          <a:prstGeom prst="rect">
-            <a:avLst/>
-          </a:prstGeom>
-          <a:noFill/>
-        </p:spPr>
-        <p:txBody>
-          <a:bodyPr wrap="square" lIns="36576" rIns="36576" tIns="36576" bIns="36576" anchor="t">
-            <a:spAutoFit/>
-          </a:bodyPr>
-          <a:lstStyle/>
-          <a:p>
-            <a:pPr algn="l"/>
+          <p:cNvPr id="7" name="TextBox 6"/>
+          <p:cNvSpPr txBox="1"/>
+          <p:nvPr/>
+        </p:nvSpPr>
+        <p:spPr>
+          <a:xfrm>
+            <a:off x="731520" y="2852928"/>
+            <a:ext cx="10698480" cy="228600"/>
+          </a:xfrm>
+          <a:prstGeom prst="rect">
+            <a:avLst/>
+          </a:prstGeom>
+          <a:noFill/>
+        </p:spPr>
+        <p:txBody>
+          <a:bodyPr wrap="square" lIns="36576" rIns="36576" tIns="36576" bIns="36576" anchor="t">
+            <a:spAutoFit/>
+          </a:bodyPr>
+          <a:lstStyle/>
+          <a:p>
+            <a:pPr algn="ctr"/>
+            <a:r>
+              <a:rPr sz="900" b="1">
+                <a:solidFill>
+                  <a:srgbClr val="C6F432"/>
+                </a:solidFill>
+                <a:latin typeface="Courier New"/>
+              </a:rPr>
+              <a:t>PRESENTED BY</a:t>
+            </a:r>
+          </a:p>
+        </p:txBody>
+      </p:sp>
+      <p:sp>
+        <p:nvSpPr>
+          <p:cNvPr id="8" name="TextBox 7"/>
+          <p:cNvSpPr txBox="1"/>
+          <p:nvPr/>
+        </p:nvSpPr>
+        <p:spPr>
+          <a:xfrm>
+            <a:off x="594360" y="3246120"/>
+            <a:ext cx="2148840" cy="274320"/>
+          </a:xfrm>
+          <a:prstGeom prst="rect">
+            <a:avLst/>
+          </a:prstGeom>
+          <a:noFill/>
+        </p:spPr>
+        <p:txBody>
+          <a:bodyPr wrap="square" lIns="36576" rIns="36576" tIns="36576" bIns="36576" anchor="t">
+            <a:spAutoFit/>
+          </a:bodyPr>
+          <a:lstStyle/>
+          <a:p>
+            <a:pPr algn="ctr"/>
+            <a:r>
+              <a:rPr sz="1100" b="1">
+                <a:solidFill>
+                  <a:srgbClr val="EEF0F3"/>
+                </a:solidFill>
+                <a:latin typeface="Aptos"/>
+              </a:rPr>
+              <a:t>Hitesh Sharma</a:t>
+            </a:r>
+          </a:p>
+        </p:txBody>
+      </p:sp>
+      <p:sp>
+        <p:nvSpPr>
+          <p:cNvPr id="9" name="TextBox 8"/>
+          <p:cNvSpPr txBox="1"/>
+          <p:nvPr/>
+        </p:nvSpPr>
+        <p:spPr>
+          <a:xfrm>
+            <a:off x="594360" y="3602736"/>
+            <a:ext cx="2148840" cy="210312"/>
+          </a:xfrm>
+          <a:prstGeom prst="rect">
+            <a:avLst/>
+          </a:prstGeom>
+          <a:noFill/>
+        </p:spPr>
+        <p:txBody>
+          <a:bodyPr wrap="square" lIns="36576" rIns="36576" tIns="36576" bIns="36576" anchor="t">
+            <a:spAutoFit/>
+          </a:bodyPr>
+          <a:lstStyle/>
+          <a:p>
+            <a:pPr algn="ctr"/>
+            <a:r>
+              <a:rPr sz="850" b="0">
+                <a:solidFill>
+                  <a:srgbClr val="AEB8C4"/>
+                </a:solidFill>
+                <a:latin typeface="Courier New"/>
+              </a:rPr>
+              <a:t>1BM23CS114</a:t>
+            </a:r>
+          </a:p>
+        </p:txBody>
+      </p:sp>
+      <p:sp>
+        <p:nvSpPr>
+          <p:cNvPr id="10" name="TextBox 9"/>
+          <p:cNvSpPr txBox="1"/>
+          <p:nvPr/>
+        </p:nvSpPr>
+        <p:spPr>
+          <a:xfrm>
+            <a:off x="3154680" y="3246120"/>
+            <a:ext cx="2148840" cy="274320"/>
+          </a:xfrm>
+          <a:prstGeom prst="rect">
+            <a:avLst/>
+          </a:prstGeom>
+          <a:noFill/>
+        </p:spPr>
+        <p:txBody>
+          <a:bodyPr wrap="square" lIns="36576" rIns="36576" tIns="36576" bIns="36576" anchor="t">
+            <a:spAutoFit/>
+          </a:bodyPr>
+          <a:lstStyle/>
+          <a:p>
+            <a:pPr algn="ctr"/>
+            <a:r>
+              <a:rPr sz="1100" b="1">
+                <a:solidFill>
+                  <a:srgbClr val="EEF0F3"/>
+                </a:solidFill>
+                <a:latin typeface="Aptos"/>
+              </a:rPr>
+              <a:t>Ghanshyam Sharma</a:t>
+            </a:r>
+          </a:p>
+        </p:txBody>
+      </p:sp>
+      <p:sp>
+        <p:nvSpPr>
+          <p:cNvPr id="11" name="TextBox 10"/>
+          <p:cNvSpPr txBox="1"/>
+          <p:nvPr/>
+        </p:nvSpPr>
+        <p:spPr>
+          <a:xfrm>
+            <a:off x="3154680" y="3602736"/>
+            <a:ext cx="2148840" cy="210312"/>
+          </a:xfrm>
+          <a:prstGeom prst="rect">
+            <a:avLst/>
+          </a:prstGeom>
+          <a:noFill/>
+        </p:spPr>
+        <p:txBody>
+          <a:bodyPr wrap="square" lIns="36576" rIns="36576" tIns="36576" bIns="36576" anchor="t">
+            <a:spAutoFit/>
+          </a:bodyPr>
+          <a:lstStyle/>
+          <a:p>
+            <a:pPr algn="ctr"/>
+            <a:r>
+              <a:rPr sz="850" b="0">
+                <a:solidFill>
+                  <a:srgbClr val="AEB8C4"/>
+                </a:solidFill>
+                <a:latin typeface="Courier New"/>
+              </a:rPr>
+              <a:t>1BM23CS100</a:t>
+            </a:r>
+          </a:p>
+        </p:txBody>
+      </p:sp>
+      <p:sp>
+        <p:nvSpPr>
+          <p:cNvPr id="12" name="TextBox 11"/>
+          <p:cNvSpPr txBox="1"/>
+          <p:nvPr/>
+        </p:nvSpPr>
+        <p:spPr>
+          <a:xfrm>
+            <a:off x="5715000" y="3246120"/>
+            <a:ext cx="2148840" cy="274320"/>
+          </a:xfrm>
+          <a:prstGeom prst="rect">
+            <a:avLst/>
+          </a:prstGeom>
+          <a:noFill/>
+        </p:spPr>
+        <p:txBody>
+          <a:bodyPr wrap="square" lIns="36576" rIns="36576" tIns="36576" bIns="36576" anchor="t">
+            <a:spAutoFit/>
+          </a:bodyPr>
+          <a:lstStyle/>
+          <a:p>
+            <a:pPr algn="ctr"/>
+            <a:r>
+              <a:rPr sz="1100" b="1">
+                <a:solidFill>
+                  <a:srgbClr val="EEF0F3"/>
+                </a:solidFill>
+                <a:latin typeface="Aptos"/>
+              </a:rPr>
+              <a:t>Shreyash Shaurya</a:t>
+            </a:r>
+          </a:p>
+        </p:txBody>
+      </p:sp>
+      <p:sp>
+        <p:nvSpPr>
+          <p:cNvPr id="13" name="TextBox 12"/>
+          <p:cNvSpPr txBox="1"/>
+          <p:nvPr/>
+        </p:nvSpPr>
+        <p:spPr>
+          <a:xfrm>
+            <a:off x="5715000" y="3602736"/>
+            <a:ext cx="2148840" cy="210312"/>
+          </a:xfrm>
+          <a:prstGeom prst="rect">
+            <a:avLst/>
+          </a:prstGeom>
+          <a:noFill/>
+        </p:spPr>
+        <p:txBody>
+          <a:bodyPr wrap="square" lIns="36576" rIns="36576" tIns="36576" bIns="36576" anchor="t">
+            <a:spAutoFit/>
+          </a:bodyPr>
+          <a:lstStyle/>
+          <a:p>
+            <a:pPr algn="ctr"/>
+            <a:r>
+              <a:rPr sz="850" b="0">
+                <a:solidFill>
+                  <a:srgbClr val="AEB8C4"/>
+                </a:solidFill>
+                <a:latin typeface="Courier New"/>
+              </a:rPr>
+              <a:t>1BM23CS354</a:t>
+            </a:r>
+          </a:p>
+        </p:txBody>
+      </p:sp>
+      <p:sp>
+        <p:nvSpPr>
+          <p:cNvPr id="14" name="TextBox 13"/>
+          <p:cNvSpPr txBox="1"/>
+          <p:nvPr/>
+        </p:nvSpPr>
+        <p:spPr>
+          <a:xfrm>
+            <a:off x="8275320" y="3246120"/>
+            <a:ext cx="2148840" cy="274320"/>
+          </a:xfrm>
+          <a:prstGeom prst="rect">
+            <a:avLst/>
+          </a:prstGeom>
+          <a:noFill/>
+        </p:spPr>
+        <p:txBody>
+          <a:bodyPr wrap="square" lIns="36576" rIns="36576" tIns="36576" bIns="36576" anchor="t">
+            <a:spAutoFit/>
+          </a:bodyPr>
+          <a:lstStyle/>
+          <a:p>
+            <a:pPr algn="ctr"/>
+            <a:r>
+              <a:rPr sz="1100" b="1">
+                <a:solidFill>
+                  <a:srgbClr val="EEF0F3"/>
+                </a:solidFill>
+                <a:latin typeface="Aptos"/>
+              </a:rPr>
+              <a:t>Utkrisht Umang</a:t>
+            </a:r>
+          </a:p>
+        </p:txBody>
+      </p:sp>
+      <p:sp>
+        <p:nvSpPr>
+          <p:cNvPr id="15" name="TextBox 14"/>
+          <p:cNvSpPr txBox="1"/>
+          <p:nvPr/>
+        </p:nvSpPr>
+        <p:spPr>
+          <a:xfrm>
+            <a:off x="8275320" y="3602736"/>
+            <a:ext cx="2148840" cy="210312"/>
+          </a:xfrm>
+          <a:prstGeom prst="rect">
+            <a:avLst/>
+          </a:prstGeom>
+          <a:noFill/>
+        </p:spPr>
+        <p:txBody>
+          <a:bodyPr wrap="square" lIns="36576" rIns="36576" tIns="36576" bIns="36576" anchor="t">
+            <a:spAutoFit/>
+          </a:bodyPr>
+          <a:lstStyle/>
+          <a:p>
+            <a:pPr algn="ctr"/>
+            <a:r>
+              <a:rPr sz="850" b="0">
+                <a:solidFill>
+                  <a:srgbClr val="AEB8C4"/>
+                </a:solidFill>
+                <a:latin typeface="Courier New"/>
+              </a:rPr>
+              <a:t>1BM23CS355</a:t>
+            </a:r>
+          </a:p>
+        </p:txBody>
+      </p:sp>
+      <p:sp>
+        <p:nvSpPr>
+          <p:cNvPr id="16" name="TextBox 15"/>
+          <p:cNvSpPr txBox="1"/>
+          <p:nvPr/>
+        </p:nvSpPr>
+        <p:spPr>
+          <a:xfrm>
+            <a:off x="731520" y="4160520"/>
+            <a:ext cx="10698480" cy="210312"/>
+          </a:xfrm>
+          <a:prstGeom prst="rect">
+            <a:avLst/>
+          </a:prstGeom>
+          <a:noFill/>
+        </p:spPr>
+        <p:txBody>
+          <a:bodyPr wrap="square" lIns="36576" rIns="36576" tIns="36576" bIns="36576" anchor="t">
+            <a:spAutoFit/>
+          </a:bodyPr>
+          <a:lstStyle/>
+          <a:p>
+            <a:pPr algn="ctr"/>
             <a:r>
               <a:rPr sz="800" b="1">
                 <a:solidFill>
+                  <a:srgbClr val="C6F432"/>
+                </a:solidFill>
+                <a:latin typeface="Courier New"/>
+              </a:rPr>
+              <a:t>UNDER THE GUIDANCE OF</a:t>
+            </a:r>
+          </a:p>
+        </p:txBody>
+      </p:sp>
+      <p:sp>
+        <p:nvSpPr>
+          <p:cNvPr id="17" name="TextBox 16"/>
+          <p:cNvSpPr txBox="1"/>
+          <p:nvPr/>
+        </p:nvSpPr>
+        <p:spPr>
+          <a:xfrm>
+            <a:off x="731520" y="4407408"/>
+            <a:ext cx="10698480" cy="274320"/>
+          </a:xfrm>
+          <a:prstGeom prst="rect">
+            <a:avLst/>
+          </a:prstGeom>
+          <a:noFill/>
+        </p:spPr>
+        <p:txBody>
+          <a:bodyPr wrap="square" lIns="36576" rIns="36576" tIns="36576" bIns="36576" anchor="t">
+            <a:spAutoFit/>
+          </a:bodyPr>
+          <a:lstStyle/>
+          <a:p>
+            <a:pPr algn="ctr"/>
+            <a:r>
+              <a:rPr sz="1500" b="1">
+                <a:solidFill>
+                  <a:srgbClr val="EEF0F3"/>
+                </a:solidFill>
+                <a:latin typeface="Aptos"/>
+              </a:rPr>
+              <a:t>Rajeshwari K</a:t>
+            </a:r>
+          </a:p>
+        </p:txBody>
+      </p:sp>
+      <p:sp>
+        <p:nvSpPr>
+          <p:cNvPr id="18" name="TextBox 17"/>
+          <p:cNvSpPr txBox="1"/>
+          <p:nvPr/>
+        </p:nvSpPr>
+        <p:spPr>
+          <a:xfrm>
+            <a:off x="731520" y="4736592"/>
+            <a:ext cx="10698480" cy="210312"/>
+          </a:xfrm>
+          <a:prstGeom prst="rect">
+            <a:avLst/>
+          </a:prstGeom>
+          <a:noFill/>
+        </p:spPr>
+        <p:txBody>
+          <a:bodyPr wrap="square" lIns="36576" rIns="36576" tIns="36576" bIns="36576" anchor="t">
+            <a:spAutoFit/>
+          </a:bodyPr>
+          <a:lstStyle/>
+          <a:p>
+            <a:pPr algn="ctr"/>
+            <a:r>
+              <a:rPr sz="1000" b="0">
+                <a:solidFill>
                   <a:srgbClr val="AEB8C4"/>
                 </a:solidFill>
-                <a:latin typeface="Courier New"/>
-              </a:rPr>
-              <a:t>INPUT</a:t>
-            </a:r>
-          </a:p>
-        </p:txBody>
-      </p:sp>
-      <p:sp>
-        <p:nvSpPr>
-          <p:cNvPr id="22" name="TextBox 21"/>
-          <p:cNvSpPr txBox="1"/>
-          <p:nvPr/>
-        </p:nvSpPr>
-        <p:spPr>
-          <a:xfrm>
-            <a:off x="8732520" y="3227832"/>
-            <a:ext cx="2286000" cy="246888"/>
-          </a:xfrm>
-          <a:prstGeom prst="rect">
-            <a:avLst/>
-          </a:prstGeom>
-          <a:noFill/>
-        </p:spPr>
-        <p:txBody>
-          <a:bodyPr wrap="square" lIns="36576" rIns="36576" tIns="36576" bIns="36576" anchor="t">
-            <a:spAutoFit/>
-          </a:bodyPr>
-          <a:lstStyle/>
-          <a:p>
-            <a:pPr algn="l"/>
-            <a:r>
-              <a:rPr sz="1100" b="1">
-                <a:solidFill>
-                  <a:srgbClr val="C6F432"/>
-                </a:solidFill>
                 <a:latin typeface="Aptos"/>
               </a:rPr>
-              <a:t>headline / article</a:t>
-            </a:r>
-          </a:p>
-        </p:txBody>
-      </p:sp>
-      <p:cxnSp>
-        <p:nvCxnSpPr>
-          <p:cNvPr id="23" name="Connector 22"/>
-          <p:cNvCxnSpPr/>
-          <p:nvPr/>
-        </p:nvCxnSpPr>
-        <p:spPr>
-          <a:xfrm>
-            <a:off x="7818120" y="3886200"/>
-            <a:ext cx="3108960" cy="0"/>
-          </a:xfrm>
-          <a:prstGeom prst="line">
-            <a:avLst/>
-          </a:prstGeom>
-          <a:ln w="7620">
-            <a:solidFill>
-              <a:srgbClr val="AEB8C4"/>
-            </a:solidFill>
-          </a:ln>
-        </p:spPr>
-        <p:style>
-          <a:lnRef idx="2">
-            <a:schemeClr val="accent1"/>
-          </a:lnRef>
-          <a:fillRef idx="0">
-            <a:schemeClr val="accent1"/>
-          </a:fillRef>
-          <a:effectRef idx="1">
-            <a:schemeClr val="accent1"/>
-          </a:effectRef>
-          <a:fontRef idx="minor">
-            <a:schemeClr val="tx1"/>
-          </a:fontRef>
-        </p:style>
-      </p:cxnSp>
-      <p:sp>
-        <p:nvSpPr>
-          <p:cNvPr id="24" name="TextBox 23"/>
-          <p:cNvSpPr txBox="1"/>
-          <p:nvPr/>
-        </p:nvSpPr>
-        <p:spPr>
-          <a:xfrm>
-            <a:off x="7818120" y="3995928"/>
-            <a:ext cx="822960" cy="182880"/>
-          </a:xfrm>
-          <a:prstGeom prst="rect">
-            <a:avLst/>
-          </a:prstGeom>
-          <a:noFill/>
-        </p:spPr>
-        <p:txBody>
-          <a:bodyPr wrap="square" lIns="36576" rIns="36576" tIns="36576" bIns="36576" anchor="t">
-            <a:spAutoFit/>
-          </a:bodyPr>
-          <a:lstStyle/>
-          <a:p>
-            <a:pPr algn="l"/>
-            <a:r>
-              <a:rPr sz="800" b="1">
+              <a:t>Associate Professor</a:t>
+            </a:r>
+          </a:p>
+        </p:txBody>
+      </p:sp>
+      <p:sp>
+        <p:nvSpPr>
+          <p:cNvPr id="19" name="TextBox 18"/>
+          <p:cNvSpPr txBox="1"/>
+          <p:nvPr/>
+        </p:nvSpPr>
+        <p:spPr>
+          <a:xfrm>
+            <a:off x="731520" y="5230368"/>
+            <a:ext cx="10698480" cy="274320"/>
+          </a:xfrm>
+          <a:prstGeom prst="rect">
+            <a:avLst/>
+          </a:prstGeom>
+          <a:noFill/>
+        </p:spPr>
+        <p:txBody>
+          <a:bodyPr wrap="square" lIns="36576" rIns="36576" tIns="36576" bIns="36576" anchor="t">
+            <a:spAutoFit/>
+          </a:bodyPr>
+          <a:lstStyle/>
+          <a:p>
+            <a:pPr algn="ctr"/>
+            <a:r>
+              <a:rPr sz="1200" b="0">
+                <a:solidFill>
+                  <a:srgbClr val="EEF0F3"/>
+                </a:solidFill>
+                <a:latin typeface="Aptos"/>
+              </a:rPr>
+              <a:t>Department of Computer Science and Engineering</a:t>
+            </a:r>
+          </a:p>
+        </p:txBody>
+      </p:sp>
+      <p:sp>
+        <p:nvSpPr>
+          <p:cNvPr id="20" name="TextBox 19"/>
+          <p:cNvSpPr txBox="1"/>
+          <p:nvPr/>
+        </p:nvSpPr>
+        <p:spPr>
+          <a:xfrm>
+            <a:off x="731520" y="5614416"/>
+            <a:ext cx="10698480" cy="274320"/>
+          </a:xfrm>
+          <a:prstGeom prst="rect">
+            <a:avLst/>
+          </a:prstGeom>
+          <a:noFill/>
+        </p:spPr>
+        <p:txBody>
+          <a:bodyPr wrap="square" lIns="36576" rIns="36576" tIns="36576" bIns="36576" anchor="t">
+            <a:spAutoFit/>
+          </a:bodyPr>
+          <a:lstStyle/>
+          <a:p>
+            <a:pPr algn="ctr"/>
+            <a:r>
+              <a:rPr sz="1100" b="0">
                 <a:solidFill>
                   <a:srgbClr val="AEB8C4"/>
                 </a:solidFill>
-                <a:latin typeface="Courier New"/>
-              </a:rPr>
-              <a:t>MODEL</a:t>
-            </a:r>
-          </a:p>
-        </p:txBody>
-      </p:sp>
-      <p:sp>
-        <p:nvSpPr>
-          <p:cNvPr id="25" name="TextBox 24"/>
-          <p:cNvSpPr txBox="1"/>
-          <p:nvPr/>
-        </p:nvSpPr>
-        <p:spPr>
-          <a:xfrm>
-            <a:off x="8732520" y="3977640"/>
-            <a:ext cx="2286000" cy="246888"/>
-          </a:xfrm>
-          <a:prstGeom prst="rect">
-            <a:avLst/>
-          </a:prstGeom>
-          <a:noFill/>
-        </p:spPr>
-        <p:txBody>
-          <a:bodyPr wrap="square" lIns="36576" rIns="36576" tIns="36576" bIns="36576" anchor="t">
-            <a:spAutoFit/>
-          </a:bodyPr>
-          <a:lstStyle/>
-          <a:p>
-            <a:pPr algn="l"/>
-            <a:r>
-              <a:rPr sz="1100" b="1">
-                <a:solidFill>
-                  <a:srgbClr val="F2A900"/>
-                </a:solidFill>
                 <a:latin typeface="Aptos"/>
               </a:rPr>
-              <a:t>TF-IDF + Logistic Regression</a:t>
-            </a:r>
-          </a:p>
-        </p:txBody>
-      </p:sp>
-      <p:cxnSp>
-        <p:nvCxnSpPr>
-          <p:cNvPr id="26" name="Connector 25"/>
-          <p:cNvCxnSpPr/>
-          <p:nvPr/>
-        </p:nvCxnSpPr>
-        <p:spPr>
-          <a:xfrm>
-            <a:off x="7818120" y="4636007"/>
-            <a:ext cx="3108960" cy="0"/>
-          </a:xfrm>
-          <a:prstGeom prst="line">
-            <a:avLst/>
-          </a:prstGeom>
-          <a:ln w="7620">
-            <a:solidFill>
-              <a:srgbClr val="AEB8C4"/>
-            </a:solidFill>
-          </a:ln>
-        </p:spPr>
-        <p:style>
-          <a:lnRef idx="2">
-            <a:schemeClr val="accent1"/>
-          </a:lnRef>
-          <a:fillRef idx="0">
-            <a:schemeClr val="accent1"/>
-          </a:fillRef>
-          <a:effectRef idx="1">
-            <a:schemeClr val="accent1"/>
-          </a:effectRef>
-          <a:fontRef idx="minor">
-            <a:schemeClr val="tx1"/>
-          </a:fontRef>
-        </p:style>
-      </p:cxnSp>
-      <p:sp>
-        <p:nvSpPr>
-          <p:cNvPr id="27" name="TextBox 26"/>
-          <p:cNvSpPr txBox="1"/>
-          <p:nvPr/>
-        </p:nvSpPr>
-        <p:spPr>
-          <a:xfrm>
-            <a:off x="7818120" y="4745736"/>
-            <a:ext cx="822960" cy="182880"/>
-          </a:xfrm>
-          <a:prstGeom prst="rect">
-            <a:avLst/>
-          </a:prstGeom>
-          <a:noFill/>
-        </p:spPr>
-        <p:txBody>
-          <a:bodyPr wrap="square" lIns="36576" rIns="36576" tIns="36576" bIns="36576" anchor="t">
-            <a:spAutoFit/>
-          </a:bodyPr>
-          <a:lstStyle/>
-          <a:p>
-            <a:pPr algn="l"/>
-            <a:r>
-              <a:rPr sz="800" b="1">
-                <a:solidFill>
-                  <a:srgbClr val="AEB8C4"/>
-                </a:solidFill>
-                <a:latin typeface="Courier New"/>
-              </a:rPr>
-              <a:t>OUTPUT</a:t>
-            </a:r>
-          </a:p>
-        </p:txBody>
-      </p:sp>
-      <p:sp>
-        <p:nvSpPr>
-          <p:cNvPr id="28" name="TextBox 27"/>
-          <p:cNvSpPr txBox="1"/>
-          <p:nvPr/>
-        </p:nvSpPr>
-        <p:spPr>
-          <a:xfrm>
-            <a:off x="8732520" y="4727448"/>
-            <a:ext cx="2286000" cy="246888"/>
-          </a:xfrm>
-          <a:prstGeom prst="rect">
-            <a:avLst/>
-          </a:prstGeom>
-          <a:noFill/>
-        </p:spPr>
-        <p:txBody>
-          <a:bodyPr wrap="square" lIns="36576" rIns="36576" tIns="36576" bIns="36576" anchor="t">
-            <a:spAutoFit/>
-          </a:bodyPr>
-          <a:lstStyle/>
-          <a:p>
-            <a:pPr algn="l"/>
-            <a:r>
-              <a:rPr sz="1100" b="1">
-                <a:solidFill>
-                  <a:srgbClr val="C6F432"/>
-                </a:solidFill>
-                <a:latin typeface="Aptos"/>
-              </a:rPr>
-              <a:t>score + evidence</a:t>
-            </a:r>
-          </a:p>
-        </p:txBody>
-      </p:sp>
-      <p:sp>
-        <p:nvSpPr>
-          <p:cNvPr id="29" name="TextBox 28"/>
-          <p:cNvSpPr txBox="1"/>
-          <p:nvPr/>
-        </p:nvSpPr>
-        <p:spPr>
-          <a:xfrm>
-            <a:off x="7818120" y="5440680"/>
-            <a:ext cx="3017520" cy="228600"/>
-          </a:xfrm>
-          <a:prstGeom prst="rect">
-            <a:avLst/>
-          </a:prstGeom>
-          <a:noFill/>
-        </p:spPr>
-        <p:txBody>
-          <a:bodyPr wrap="square" lIns="36576" rIns="36576" tIns="36576" bIns="36576" anchor="t">
-            <a:spAutoFit/>
-          </a:bodyPr>
-          <a:lstStyle/>
-          <a:p>
-            <a:pPr algn="l"/>
-            <a:r>
-              <a:rPr sz="900" b="1">
-                <a:solidFill>
-                  <a:srgbClr val="C6F432"/>
-                </a:solidFill>
-                <a:latin typeface="Courier New"/>
-              </a:rPr>
-              <a:t>HUMAN-IN-THE-LOOP</a:t>
-            </a:r>
-          </a:p>
-        </p:txBody>
-      </p:sp>
-      <p:sp>
-        <p:nvSpPr>
-          <p:cNvPr id="30" name="TextBox 29"/>
-          <p:cNvSpPr txBox="1"/>
-          <p:nvPr/>
-        </p:nvSpPr>
-        <p:spPr>
-          <a:xfrm>
-            <a:off x="7818120" y="5650992"/>
-            <a:ext cx="3063240" cy="274320"/>
-          </a:xfrm>
-          <a:prstGeom prst="rect">
-            <a:avLst/>
-          </a:prstGeom>
-          <a:noFill/>
-        </p:spPr>
-        <p:txBody>
-          <a:bodyPr wrap="square" lIns="36576" rIns="36576" tIns="36576" bIns="36576" anchor="t">
-            <a:spAutoFit/>
-          </a:bodyPr>
-          <a:lstStyle/>
-          <a:p>
-            <a:pPr algn="l"/>
-            <a:r>
-              <a:rPr sz="1000" b="0">
-                <a:solidFill>
-                  <a:srgbClr val="AEB8C4"/>
-                </a:solidFill>
-                <a:latin typeface="Aptos"/>
-              </a:rPr>
-              <a:t>A screening aid, never a truth verdict.</a:t>
+              <a:t>B.M.S. College of Engineering</a:t>
             </a:r>
           </a:p>
         </p:txBody>
@@ -4369,7 +4018,7 @@
                 </a:solidFill>
                 <a:latin typeface="Cambria"/>
               </a:rPr>
-              <a:t>Identify language patterns that make a news headline or article deserve verification before it is shared.</a:t>
+              <a:t>A user may see a headline before checking the source. NewsLens gives a quick language-based signal for deciding whether the text needs verification.</a:t>
             </a:r>
           </a:p>
         </p:txBody>
@@ -4404,7 +4053,7 @@
                 </a:solidFill>
                 <a:latin typeface="Aptos"/>
               </a:rPr>
-              <a:t>A sensational claim can look persuasive, while legitimate reporting can be written in urgent language. The system must provide a signal with reasons—not an unsupported verdict.</a:t>
+              <a:t>The output is not a fact-check. It is a prediction learned from labelled examples, so a person must still check the publisher, date, author and supporting evidence.</a:t>
             </a:r>
           </a:p>
         </p:txBody>
@@ -4544,7 +4193,7 @@
                 </a:solidFill>
                 <a:latin typeface="Aptos"/>
               </a:rPr>
-              <a:t>Train on a genuine labelled news dataset with reproducible evaluation.</a:t>
+              <a:t>Train with Fake.csv and True.csv and evaluate on a held-out split.</a:t>
             </a:r>
           </a:p>
         </p:txBody>
@@ -4649,7 +4298,7 @@
                 </a:solidFill>
                 <a:latin typeface="Aptos"/>
               </a:rPr>
-              <a:t>Route short headlines and longer articles through suitable models.</a:t>
+              <a:t>Use one model for headlines and another for longer articles.</a:t>
             </a:r>
           </a:p>
         </p:txBody>
@@ -4754,7 +4403,7 @@
                 </a:solidFill>
                 <a:latin typeface="Aptos"/>
               </a:rPr>
-              <a:t>Explain the result and keep a human responsible for verification.</a:t>
+              <a:t>Return a score, model name, language signals and a caution message.</a:t>
             </a:r>
           </a:p>
         </p:txBody>
@@ -4834,7 +4483,7 @@
                 </a:solidFill>
                 <a:latin typeface="Courier New"/>
               </a:rPr>
-              <a:t>Scope: English binary screening · local model artifact · Flask API · responsive browser interface</a:t>
+              <a:t>Scope: English text · two labels · local model artifact · Flask API · browser interface</a:t>
             </a:r>
           </a:p>
         </p:txBody>
@@ -4975,7 +4624,7 @@
                 </a:solidFill>
                 <a:latin typeface="Cambria"/>
               </a:rPr>
-              <a:t>Related work and research gap</a:t>
+              <a:t>NLP terms used in NewsLens</a:t>
             </a:r>
           </a:p>
         </p:txBody>
@@ -5045,7 +4694,7 @@
                 </a:solidFill>
                 <a:latin typeface="Courier New"/>
               </a:rPr>
-              <a:t>RELATED WORK</a:t>
+              <a:t>KEY VOCABULARY</a:t>
             </a:r>
           </a:p>
         </p:txBody>
@@ -5115,7 +4764,7 @@
                 </a:solidFill>
                 <a:latin typeface="Cambria"/>
               </a:rPr>
-              <a:t>LIAR benchmark</a:t>
+              <a:t>Tokenization</a:t>
             </a:r>
           </a:p>
         </p:txBody>
@@ -5150,7 +4799,7 @@
                 </a:solidFill>
                 <a:latin typeface="Aptos"/>
               </a:rPr>
-              <a:t>12.8K manually labelled short statements from PolitiFact; useful for claim-level research.</a:t>
+              <a:t>Splitting the input into words so the vectorizer can process the text.</a:t>
             </a:r>
           </a:p>
         </p:txBody>
@@ -5220,7 +4869,7 @@
                 </a:solidFill>
                 <a:latin typeface="Cambria"/>
               </a:rPr>
-              <a:t>FakeNewsNet</a:t>
+              <a:t>TF-IDF</a:t>
             </a:r>
           </a:p>
         </p:txBody>
@@ -5255,7 +4904,7 @@
                 </a:solidFill>
                 <a:latin typeface="Aptos"/>
               </a:rPr>
-              <a:t>News content plus social-context research data; collection is constrained by copyright and platform policies.</a:t>
+              <a:t>Giving more weight to useful words and less weight to words common in many documents.</a:t>
             </a:r>
           </a:p>
         </p:txBody>
@@ -5325,7 +4974,7 @@
                 </a:solidFill>
                 <a:latin typeface="Cambria"/>
               </a:rPr>
-              <a:t>Text classifiers</a:t>
+              <a:t>Classification</a:t>
             </a:r>
           </a:p>
         </p:txBody>
@@ -5360,7 +5009,7 @@
                 </a:solidFill>
                 <a:latin typeface="Aptos"/>
               </a:rPr>
-              <a:t>TF-IDF and linear models provide a fast, interpretable baseline for an academic deployment.</a:t>
+              <a:t>Learning a relationship between text features and the two dataset labels.</a:t>
             </a:r>
           </a:p>
         </p:txBody>
@@ -5440,7 +5089,7 @@
                 </a:solidFill>
                 <a:latin typeface="Courier New"/>
               </a:rPr>
-              <a:t>OUR CONTRIBUTION</a:t>
+              <a:t>IMPLEMENTATION CHOICES</a:t>
             </a:r>
           </a:p>
         </p:txBody>
@@ -5475,7 +5124,7 @@
                 </a:solidFill>
                 <a:latin typeface="Cambria"/>
               </a:rPr>
-              <a:t>Project focus</a:t>
+              <a:t>Why this baseline?</a:t>
             </a:r>
           </a:p>
         </p:txBody>
@@ -5510,7 +5159,7 @@
                 </a:solidFill>
                 <a:latin typeface="Aptos"/>
               </a:rPr>
-              <a:t>A compact, explainable detector that distinguishes headline inputs from full article inputs and makes uncertainty visible.</a:t>
+              <a:t>TF-IDF with Logistic Regression is fast to train, simple to inspect and practical for a college web application.</a:t>
             </a:r>
           </a:p>
         </p:txBody>
@@ -5580,7 +5229,7 @@
                 </a:solidFill>
                 <a:latin typeface="Cambria"/>
               </a:rPr>
-              <a:t>Our approach</a:t>
+              <a:t>Two input modes</a:t>
             </a:r>
           </a:p>
         </p:txBody>
@@ -5615,7 +5264,7 @@
                 </a:solidFill>
                 <a:latin typeface="Aptos"/>
               </a:rPr>
-              <a:t>Use the ISOT dataset, train separate TF-IDF + Logistic Regression pipelines, expose a Flask API, and require human source verification.</a:t>
+              <a:t>A headline uses title text only. A longer input uses title plus article text. The API shows which model was selected.</a:t>
             </a:r>
           </a:p>
         </p:txBody>
@@ -5650,7 +5299,7 @@
                 </a:solidFill>
                 <a:latin typeface="Courier New"/>
               </a:rPr>
-              <a:t>Gap addressed: many demos return a label; NewsLens pairs a model output with input-aware routing, provenance, metrics, and ethical guidance.</a:t>
+              <a:t>Important: a high score means the language resembles the fake class in this dataset; it does not prove that the claim is false.</a:t>
             </a:r>
           </a:p>
         </p:txBody>
@@ -6137,8 +5786,8 @@
                 </a:solidFill>
                 <a:latin typeface="Aptos"/>
               </a:rPr>
-              <a:t>spaCy
-tokenization</a:t>
+              <a:t>tokenize
+text</a:t>
             </a:r>
           </a:p>
         </p:txBody>
@@ -6298,8 +5947,8 @@
                 </a:solidFill>
                 <a:latin typeface="Aptos"/>
               </a:rPr>
-              <a:t>bounded
-word TF-IDF</a:t>
+              <a:t>word
+TF-IDF</a:t>
             </a:r>
           </a:p>
         </p:txBody>
@@ -7254,8 +6903,8 @@
                 </a:solidFill>
                 <a:latin typeface="Aptos"/>
               </a:rPr>
-              <a:t>probability
-+ signals</a:t>
+              <a:t>score +
+signals</a:t>
             </a:r>
           </a:p>
         </p:txBody>
@@ -7415,8 +7064,8 @@
                 </a:solidFill>
                 <a:latin typeface="Aptos"/>
               </a:rPr>
-              <a:t>human
-source check</a:t>
+              <a:t>check
+source</a:t>
             </a:r>
           </a:p>
         </p:txBody>
@@ -7490,13 +7139,13 @@
           <a:p>
             <a:pPr algn="ctr"/>
             <a:r>
-              <a:rPr sz="1100" b="1">
+              <a:rPr sz="1000" b="1">
                 <a:solidFill>
                   <a:srgbClr val="EEF0F3"/>
                 </a:solidFill>
                 <a:latin typeface="Courier New"/>
               </a:rPr>
-              <a:t>API: GET /api/health  ·  POST /api/analyze  ·  Model loads a saved artifact; startup does not retrain.</a:t>
+              <a:t>Run: python training/train_model.py --input data  ·  Start: python server.py  ·  API: POST /api/analyze</a:t>
             </a:r>
           </a:p>
         </p:txBody>
@@ -8367,7 +8016,7 @@
                 </a:solidFill>
                 <a:latin typeface="Aptos"/>
               </a:rPr>
-              <a:t>Actual labelled rows from True.csv and Fake.csv produced the expected lower-risk and high-risk outcomes.</a:t>
+              <a:t>The dataset contains 44,898 usable articles; 35,918 were used for training and 8,980 for testing.</a:t>
             </a:r>
           </a:p>
         </p:txBody>
@@ -8437,7 +8086,7 @@
                 </a:solidFill>
                 <a:latin typeface="Aptos"/>
               </a:rPr>
-              <a:t>Short inputs route to the headline model; full articles route to the article model.</a:t>
+              <a:t>Article model: 99.31% accuracy and 99.34% F1 on the held-out split.</a:t>
             </a:r>
           </a:p>
         </p:txBody>
@@ -8507,7 +8156,7 @@
                 </a:solidFill>
                 <a:latin typeface="Aptos"/>
               </a:rPr>
-              <a:t>Random holdout metrics are not proof of real-world factual accuracy; publisher and topic leakage remain risks.</a:t>
+              <a:t>Headline model: 96.16% accuracy and 96.29% F1 on the held-out split.</a:t>
             </a:r>
           </a:p>
         </p:txBody>
@@ -8622,7 +8271,7 @@
                 </a:solidFill>
                 <a:latin typeface="Cambria"/>
               </a:rPr>
-              <a:t>NewsLens turns NLP signals into a transparent verification aid—not an autonomous truth engine.</a:t>
+              <a:t>The system works as a screening aid. It still makes mistakes when the dataset and real-world context are different.</a:t>
             </a:r>
           </a:p>
         </p:txBody>
@@ -8657,7 +8306,7 @@
                 </a:solidFill>
                 <a:latin typeface="Courier New"/>
               </a:rPr>
-              <a:t>Pause · inspect the evidence · verify before sharing.</a:t>
+              <a:t>Use the score to start verification, not to replace it.</a:t>
             </a:r>
           </a:p>
         </p:txBody>

</xml_diff>